<commit_message>
Package updated timeline app and five-slide presentation for USB submission
</commit_message>
<xml_diff>
--- a/deliverables/uidongi-pick-presentation.pptx
+++ b/deliverables/uidongi-pick-presentation.pptx
@@ -716,7 +716,7 @@
           <a:lstStyle/>
           <a:p>
             <a:r>
-              <a:t>이 화면은 발표용으로 그린 목업이 아니라 실제 USB 패키지를 실행해 캡처한 결과입니다. 예시에서는 가족 여행과 여섯 시간의 활동 예산을 선택했습니다. 화면의 체류시간 295분과 사용자가 지정한 이동 여유 60분을 합쳐 355분이 표시됩니다. 이 이동 여유는 실제 도로 이동시간이 아닙니다. 각 장소 아래 초록색 체크에는 가족 여행이나 관심사처럼 데이터와 일치한 조건을 보여줍니다. 점심시간 이유는 실제 배치한 시간대가 맞을 때만 붙습니다. 이동시간이 없는 구간은 숫자를 만들지 않고 확인 필요로 표시하며, 그 이후 시각은 확정이 아닌 최소 시각의 임시 일정으로 안내합니다. 검색과 필터를 바꾼 뒤 같은 방식으로 결과를 비교할 수 있습니다.</a:t>
+              <a:t>이 화면은 발표용으로 그린 목업이 아니라 실제 USB 패키지를 실행해 캡처한 결과입니다. 예시에서는 가족 여행과 여섯 시간의 활동 예산을 선택했습니다. 등록된 체류시간과 사용자가 입력한 이동 여유를 합산해 시간 예산에 맞춥니다. 이 이동 여유는 실제 도로 이동시간이 아닙니다. 유형 색상과 방문 번호로 순서를 읽고 날짜별 버튼으로 확인할 수 있습니다. 각 장소의 초록 체크에는 동행, 관심사, 예산과 권역 등 데이터와 일치한 조건을 보여줍니다. 등록된 일인 금액만 합산하고 교통비와 미등록 항목은 제외합니다. 점심시간 이유는 실제 배치한 시간대가 맞을 때만 붙습니다. 이동시간이 없는 구간은 숫자를 만들지 않고 확인 필요로 표시하며, 그 이후 시각은 확정이 아닌 최소 시각의 임시 일정으로 안내합니다. 검색과 필터를 바꾼 뒤 같은 방식으로 결과를 비교할 수 있습니다.</a:t>
             </a:r>
           </a:p>
         </p:txBody>
@@ -8837,7 +8837,7 @@
               </a:defRPr>
             </a:pPr>
             <a:r>
-              <a:t>시간표와 추천 이유를 한 화면에서 확인합니다</a:t>
+              <a:t>날짜별 여행 카드와 추천 이유를 확인합니다</a:t>
             </a:r>
           </a:p>
         </p:txBody>
@@ -9051,7 +9051,7 @@
       </p:sp>
       <p:pic>
         <p:nvPicPr>
-          <p:cNvPr id="12" name="Picture 11" descr="화면_일정.png"/>
+          <p:cNvPr id="12" name="Picture 11" descr="화면_카드.png"/>
           <p:cNvPicPr>
             <a:picLocks noChangeAspect="1"/>
           </p:cNvPicPr>
@@ -9059,15 +9059,14 @@
         </p:nvPicPr>
         <p:blipFill>
           <a:blip r:embed="rId2"/>
-          <a:srcRect l="8000" r="8000" t="30000" b="10500"/>
           <a:stretch>
             <a:fillRect/>
           </a:stretch>
         </p:blipFill>
         <p:spPr>
           <a:xfrm>
-            <a:off x="658368" y="2377440"/>
-            <a:ext cx="7498079" cy="3685032"/>
+            <a:off x="1982288" y="2395728"/>
+            <a:ext cx="4859382" cy="3657600"/>
           </a:xfrm>
           <a:prstGeom prst="rect">
             <a:avLst/>
@@ -9108,7 +9107,7 @@
               </a:defRPr>
             </a:pPr>
             <a:r>
-              <a:t>✓ 시간 예산 확인</a:t>
+              <a:t>✓ 시간순 일정 카드</a:t>
             </a:r>
           </a:p>
         </p:txBody>
@@ -9147,7 +9146,7 @@
               </a:defRPr>
             </a:pPr>
             <a:r>
-              <a:t>체류시간과 입력한 이동 여유를</a:t>
+              <a:t>방문 순서·시각·유형별 카드</a:t>
             </a:r>
           </a:p>
           <a:p>
@@ -9163,7 +9162,7 @@
               </a:defRPr>
             </a:pPr>
             <a:r>
-              <a:t>합산해 방문 후보를 배치</a:t>
+              <a:t>날짜 선택과 조건 재수정</a:t>
             </a:r>
           </a:p>
         </p:txBody>
@@ -9241,7 +9240,7 @@
               </a:defRPr>
             </a:pPr>
             <a:r>
-              <a:t>동행·관심사·점심시간 등</a:t>
+              <a:t>동행·관심사·예산·권역 등</a:t>
             </a:r>
           </a:p>
           <a:p>
@@ -9335,7 +9334,7 @@
               </a:defRPr>
             </a:pPr>
             <a:r>
-              <a:t>가상 업소는 실제 지도·예약 제외</a:t>
+              <a:t>합산 가능한 1인 금액과 제외 항목</a:t>
             </a:r>
           </a:p>
           <a:p>
@@ -9351,7 +9350,7 @@
               </a:defRPr>
             </a:pPr>
             <a:r>
-              <a:t>미확인 이동·운영은 확인 필요</a:t>
+              <a:t>미확인 위치는 지도 연결 제외</a:t>
             </a:r>
           </a:p>
         </p:txBody>

</xml_diff>